<commit_message>
Moving things around to make space for W10 C++.
</commit_message>
<xml_diff>
--- a/W5/W5S2 - RegEx/W5S2.pptx
+++ b/W5/W5S2 - RegEx/W5S2.pptx
@@ -329,7 +329,7 @@
 <file path=ppt/revisionInfo.xml><?xml version="1.0" encoding="utf-8"?>
 <p1510:revInfo xmlns:a="http://schemas.openxmlformats.org/drawingml/2006/main" xmlns:r="http://schemas.openxmlformats.org/officeDocument/2006/relationships" xmlns:p1510="http://schemas.microsoft.com/office/powerpoint/2015/10/main">
   <p1510:revLst>
-    <p1510:client id="{681CBE4F-CC71-4C63-997E-D1757BF8379E}" v="2" dt="2026-01-14T08:47:23.150"/>
+    <p1510:client id="{79218A5F-0102-4BA6-9DFB-22CE95F5F93F}" v="1" dt="2026-02-24T03:51:37.079"/>
   </p1510:revLst>
 </p1510:revInfo>
 </file>
@@ -339,18 +339,33 @@
   <pc:docChgLst>
     <pc:chgData name="Matthieu De Mari" userId="dfb708c9-d8dc-439f-9a3b-c772bf4a311c" providerId="ADAL" clId="{81E9B007-0C2C-493E-9B93-55A62C9C1F12}"/>
     <pc:docChg chg="custSel modSld">
-      <pc:chgData name="Matthieu De Mari" userId="dfb708c9-d8dc-439f-9a3b-c772bf4a311c" providerId="ADAL" clId="{81E9B007-0C2C-493E-9B93-55A62C9C1F12}" dt="2026-01-14T08:48:42.334" v="155" actId="14100"/>
+      <pc:chgData name="Matthieu De Mari" userId="dfb708c9-d8dc-439f-9a3b-c772bf4a311c" providerId="ADAL" clId="{81E9B007-0C2C-493E-9B93-55A62C9C1F12}" dt="2026-02-24T03:51:37.079" v="209"/>
       <pc:docMkLst>
         <pc:docMk/>
       </pc:docMkLst>
       <pc:sldChg chg="modSp mod">
-        <pc:chgData name="Matthieu De Mari" userId="dfb708c9-d8dc-439f-9a3b-c772bf4a311c" providerId="ADAL" clId="{81E9B007-0C2C-493E-9B93-55A62C9C1F12}" dt="2026-01-14T08:42:00.123" v="10" actId="20577"/>
+        <pc:chgData name="Matthieu De Mari" userId="dfb708c9-d8dc-439f-9a3b-c772bf4a311c" providerId="ADAL" clId="{81E9B007-0C2C-493E-9B93-55A62C9C1F12}" dt="2026-02-24T02:54:07.992" v="156" actId="400"/>
+        <pc:sldMkLst>
+          <pc:docMk/>
+          <pc:sldMk cId="1794465962" sldId="424"/>
+        </pc:sldMkLst>
+        <pc:spChg chg="mod">
+          <ac:chgData name="Matthieu De Mari" userId="dfb708c9-d8dc-439f-9a3b-c772bf4a311c" providerId="ADAL" clId="{81E9B007-0C2C-493E-9B93-55A62C9C1F12}" dt="2026-02-24T02:54:07.992" v="156" actId="400"/>
+          <ac:spMkLst>
+            <pc:docMk/>
+            <pc:sldMk cId="1794465962" sldId="424"/>
+            <ac:spMk id="3" creationId="{C51ADC3A-36BE-B86B-FA40-9DF3C5E68D0A}"/>
+          </ac:spMkLst>
+        </pc:spChg>
+      </pc:sldChg>
+      <pc:sldChg chg="modSp mod">
+        <pc:chgData name="Matthieu De Mari" userId="dfb708c9-d8dc-439f-9a3b-c772bf4a311c" providerId="ADAL" clId="{81E9B007-0C2C-493E-9B93-55A62C9C1F12}" dt="2026-02-24T03:51:29.683" v="208" actId="20577"/>
         <pc:sldMkLst>
           <pc:docMk/>
           <pc:sldMk cId="1448790682" sldId="441"/>
         </pc:sldMkLst>
         <pc:spChg chg="mod">
-          <ac:chgData name="Matthieu De Mari" userId="dfb708c9-d8dc-439f-9a3b-c772bf4a311c" providerId="ADAL" clId="{81E9B007-0C2C-493E-9B93-55A62C9C1F12}" dt="2026-01-14T08:42:00.123" v="10" actId="20577"/>
+          <ac:chgData name="Matthieu De Mari" userId="dfb708c9-d8dc-439f-9a3b-c772bf4a311c" providerId="ADAL" clId="{81E9B007-0C2C-493E-9B93-55A62C9C1F12}" dt="2026-02-24T03:51:29.683" v="208" actId="20577"/>
           <ac:spMkLst>
             <pc:docMk/>
             <pc:sldMk cId="1448790682" sldId="441"/>
@@ -358,14 +373,14 @@
           </ac:spMkLst>
         </pc:spChg>
       </pc:sldChg>
-      <pc:sldChg chg="modSp mod">
-        <pc:chgData name="Matthieu De Mari" userId="dfb708c9-d8dc-439f-9a3b-c772bf4a311c" providerId="ADAL" clId="{81E9B007-0C2C-493E-9B93-55A62C9C1F12}" dt="2026-01-14T08:42:51.360" v="102" actId="20577"/>
+      <pc:sldChg chg="modSp">
+        <pc:chgData name="Matthieu De Mari" userId="dfb708c9-d8dc-439f-9a3b-c772bf4a311c" providerId="ADAL" clId="{81E9B007-0C2C-493E-9B93-55A62C9C1F12}" dt="2026-02-24T03:51:37.079" v="209"/>
         <pc:sldMkLst>
           <pc:docMk/>
           <pc:sldMk cId="110232736" sldId="443"/>
         </pc:sldMkLst>
         <pc:spChg chg="mod">
-          <ac:chgData name="Matthieu De Mari" userId="dfb708c9-d8dc-439f-9a3b-c772bf4a311c" providerId="ADAL" clId="{81E9B007-0C2C-493E-9B93-55A62C9C1F12}" dt="2026-01-14T08:42:51.360" v="102" actId="20577"/>
+          <ac:chgData name="Matthieu De Mari" userId="dfb708c9-d8dc-439f-9a3b-c772bf4a311c" providerId="ADAL" clId="{81E9B007-0C2C-493E-9B93-55A62C9C1F12}" dt="2026-02-24T03:51:37.079" v="209"/>
           <ac:spMkLst>
             <pc:docMk/>
             <pc:sldMk cId="110232736" sldId="443"/>
@@ -374,198 +389,47 @@
         </pc:spChg>
       </pc:sldChg>
       <pc:sldChg chg="modSp mod">
-        <pc:chgData name="Matthieu De Mari" userId="dfb708c9-d8dc-439f-9a3b-c772bf4a311c" providerId="ADAL" clId="{81E9B007-0C2C-493E-9B93-55A62C9C1F12}" dt="2026-01-14T08:43:09.779" v="104" actId="115"/>
+        <pc:chgData name="Matthieu De Mari" userId="dfb708c9-d8dc-439f-9a3b-c772bf4a311c" providerId="ADAL" clId="{81E9B007-0C2C-493E-9B93-55A62C9C1F12}" dt="2026-02-24T03:45:58.383" v="180" actId="20577"/>
         <pc:sldMkLst>
           <pc:docMk/>
-          <pc:sldMk cId="4016554108" sldId="448"/>
+          <pc:sldMk cId="3521859159" sldId="457"/>
         </pc:sldMkLst>
         <pc:spChg chg="mod">
-          <ac:chgData name="Matthieu De Mari" userId="dfb708c9-d8dc-439f-9a3b-c772bf4a311c" providerId="ADAL" clId="{81E9B007-0C2C-493E-9B93-55A62C9C1F12}" dt="2026-01-14T08:43:09.779" v="104" actId="115"/>
+          <ac:chgData name="Matthieu De Mari" userId="dfb708c9-d8dc-439f-9a3b-c772bf4a311c" providerId="ADAL" clId="{81E9B007-0C2C-493E-9B93-55A62C9C1F12}" dt="2026-02-24T03:45:58.383" v="180" actId="20577"/>
           <ac:spMkLst>
             <pc:docMk/>
-            <pc:sldMk cId="4016554108" sldId="448"/>
-            <ac:spMk id="3" creationId="{98C8E745-17FA-0972-8665-9C637236AA5B}"/>
+            <pc:sldMk cId="3521859159" sldId="457"/>
+            <ac:spMk id="5" creationId="{4F0C9377-31A4-50F3-144A-62B9B92A0435}"/>
           </ac:spMkLst>
         </pc:spChg>
       </pc:sldChg>
       <pc:sldChg chg="modSp mod">
-        <pc:chgData name="Matthieu De Mari" userId="dfb708c9-d8dc-439f-9a3b-c772bf4a311c" providerId="ADAL" clId="{81E9B007-0C2C-493E-9B93-55A62C9C1F12}" dt="2026-01-14T08:43:06.584" v="103" actId="115"/>
+        <pc:chgData name="Matthieu De Mari" userId="dfb708c9-d8dc-439f-9a3b-c772bf4a311c" providerId="ADAL" clId="{81E9B007-0C2C-493E-9B93-55A62C9C1F12}" dt="2026-02-24T03:46:16.826" v="205" actId="20577"/>
         <pc:sldMkLst>
           <pc:docMk/>
-          <pc:sldMk cId="512281156" sldId="449"/>
+          <pc:sldMk cId="1844132787" sldId="458"/>
         </pc:sldMkLst>
         <pc:spChg chg="mod">
-          <ac:chgData name="Matthieu De Mari" userId="dfb708c9-d8dc-439f-9a3b-c772bf4a311c" providerId="ADAL" clId="{81E9B007-0C2C-493E-9B93-55A62C9C1F12}" dt="2026-01-14T08:43:06.584" v="103" actId="115"/>
+          <ac:chgData name="Matthieu De Mari" userId="dfb708c9-d8dc-439f-9a3b-c772bf4a311c" providerId="ADAL" clId="{81E9B007-0C2C-493E-9B93-55A62C9C1F12}" dt="2026-02-24T03:46:16.826" v="205" actId="20577"/>
           <ac:spMkLst>
             <pc:docMk/>
-            <pc:sldMk cId="512281156" sldId="449"/>
-            <ac:spMk id="3" creationId="{98C8E745-17FA-0972-8665-9C637236AA5B}"/>
-          </ac:spMkLst>
-        </pc:spChg>
-      </pc:sldChg>
-      <pc:sldChg chg="addSp delSp modSp mod">
-        <pc:chgData name="Matthieu De Mari" userId="dfb708c9-d8dc-439f-9a3b-c772bf4a311c" providerId="ADAL" clId="{81E9B007-0C2C-493E-9B93-55A62C9C1F12}" dt="2026-01-14T08:37:57.734" v="2"/>
-        <pc:sldMkLst>
-          <pc:docMk/>
-          <pc:sldMk cId="3824911825" sldId="453"/>
-        </pc:sldMkLst>
-        <pc:spChg chg="del">
-          <ac:chgData name="Matthieu De Mari" userId="dfb708c9-d8dc-439f-9a3b-c772bf4a311c" providerId="ADAL" clId="{81E9B007-0C2C-493E-9B93-55A62C9C1F12}" dt="2026-01-14T08:37:55.300" v="0" actId="478"/>
-          <ac:spMkLst>
-            <pc:docMk/>
-            <pc:sldMk cId="3824911825" sldId="453"/>
-            <ac:spMk id="4" creationId="{A0FF4252-8E53-B941-EF50-7759A6112153}"/>
-          </ac:spMkLst>
-        </pc:spChg>
-        <pc:spChg chg="add del mod">
-          <ac:chgData name="Matthieu De Mari" userId="dfb708c9-d8dc-439f-9a3b-c772bf4a311c" providerId="ADAL" clId="{81E9B007-0C2C-493E-9B93-55A62C9C1F12}" dt="2026-01-14T08:37:57.138" v="1" actId="478"/>
-          <ac:spMkLst>
-            <pc:docMk/>
-            <pc:sldMk cId="3824911825" sldId="453"/>
-            <ac:spMk id="8" creationId="{3D530F01-50FF-BF4C-1977-D8BC1A2F697D}"/>
-          </ac:spMkLst>
-        </pc:spChg>
-        <pc:spChg chg="add mod">
-          <ac:chgData name="Matthieu De Mari" userId="dfb708c9-d8dc-439f-9a3b-c772bf4a311c" providerId="ADAL" clId="{81E9B007-0C2C-493E-9B93-55A62C9C1F12}" dt="2026-01-14T08:37:57.734" v="2"/>
-          <ac:spMkLst>
-            <pc:docMk/>
-            <pc:sldMk cId="3824911825" sldId="453"/>
-            <ac:spMk id="14" creationId="{BDDF3693-513D-940D-EFD1-AD78FE2B1690}"/>
+            <pc:sldMk cId="1844132787" sldId="458"/>
+            <ac:spMk id="5" creationId="{4F0C9377-31A4-50F3-144A-62B9B92A0435}"/>
           </ac:spMkLst>
         </pc:spChg>
       </pc:sldChg>
       <pc:sldChg chg="modSp mod">
-        <pc:chgData name="Matthieu De Mari" userId="dfb708c9-d8dc-439f-9a3b-c772bf4a311c" providerId="ADAL" clId="{81E9B007-0C2C-493E-9B93-55A62C9C1F12}" dt="2026-01-14T08:43:40.542" v="106" actId="20577"/>
-        <pc:sldMkLst>
-          <pc:docMk/>
-          <pc:sldMk cId="146061813" sldId="459"/>
-        </pc:sldMkLst>
-        <pc:spChg chg="mod">
-          <ac:chgData name="Matthieu De Mari" userId="dfb708c9-d8dc-439f-9a3b-c772bf4a311c" providerId="ADAL" clId="{81E9B007-0C2C-493E-9B93-55A62C9C1F12}" dt="2026-01-14T08:43:40.542" v="106" actId="20577"/>
-          <ac:spMkLst>
-            <pc:docMk/>
-            <pc:sldMk cId="146061813" sldId="459"/>
-            <ac:spMk id="5" creationId="{B3F89993-8E2D-39C7-D73F-D6F5D0507F8F}"/>
-          </ac:spMkLst>
-        </pc:spChg>
-      </pc:sldChg>
-      <pc:sldChg chg="modSp mod">
-        <pc:chgData name="Matthieu De Mari" userId="dfb708c9-d8dc-439f-9a3b-c772bf4a311c" providerId="ADAL" clId="{81E9B007-0C2C-493E-9B93-55A62C9C1F12}" dt="2026-01-14T08:43:58.855" v="107" actId="207"/>
-        <pc:sldMkLst>
-          <pc:docMk/>
-          <pc:sldMk cId="2491784038" sldId="460"/>
-        </pc:sldMkLst>
-        <pc:spChg chg="mod">
-          <ac:chgData name="Matthieu De Mari" userId="dfb708c9-d8dc-439f-9a3b-c772bf4a311c" providerId="ADAL" clId="{81E9B007-0C2C-493E-9B93-55A62C9C1F12}" dt="2026-01-14T08:43:58.855" v="107" actId="207"/>
-          <ac:spMkLst>
-            <pc:docMk/>
-            <pc:sldMk cId="2491784038" sldId="460"/>
-            <ac:spMk id="6" creationId="{9B6A00C8-E3FA-09B1-418B-292BC486CB87}"/>
-          </ac:spMkLst>
-        </pc:spChg>
-      </pc:sldChg>
-      <pc:sldChg chg="modSp mod">
-        <pc:chgData name="Matthieu De Mari" userId="dfb708c9-d8dc-439f-9a3b-c772bf4a311c" providerId="ADAL" clId="{81E9B007-0C2C-493E-9B93-55A62C9C1F12}" dt="2026-01-14T08:44:29.252" v="108" actId="20577"/>
-        <pc:sldMkLst>
-          <pc:docMk/>
-          <pc:sldMk cId="2636270797" sldId="461"/>
-        </pc:sldMkLst>
-        <pc:spChg chg="mod">
-          <ac:chgData name="Matthieu De Mari" userId="dfb708c9-d8dc-439f-9a3b-c772bf4a311c" providerId="ADAL" clId="{81E9B007-0C2C-493E-9B93-55A62C9C1F12}" dt="2026-01-14T08:44:29.252" v="108" actId="20577"/>
-          <ac:spMkLst>
-            <pc:docMk/>
-            <pc:sldMk cId="2636270797" sldId="461"/>
-            <ac:spMk id="3" creationId="{8821F76F-B59B-FBFA-F2D2-1D9ABA97022B}"/>
-          </ac:spMkLst>
-        </pc:spChg>
-      </pc:sldChg>
-      <pc:sldChg chg="modSp mod">
-        <pc:chgData name="Matthieu De Mari" userId="dfb708c9-d8dc-439f-9a3b-c772bf4a311c" providerId="ADAL" clId="{81E9B007-0C2C-493E-9B93-55A62C9C1F12}" dt="2026-01-14T08:47:29.164" v="150" actId="20577"/>
-        <pc:sldMkLst>
-          <pc:docMk/>
-          <pc:sldMk cId="2960715248" sldId="464"/>
-        </pc:sldMkLst>
-        <pc:spChg chg="mod">
-          <ac:chgData name="Matthieu De Mari" userId="dfb708c9-d8dc-439f-9a3b-c772bf4a311c" providerId="ADAL" clId="{81E9B007-0C2C-493E-9B93-55A62C9C1F12}" dt="2026-01-14T08:47:29.164" v="150" actId="20577"/>
-          <ac:spMkLst>
-            <pc:docMk/>
-            <pc:sldMk cId="2960715248" sldId="464"/>
-            <ac:spMk id="4" creationId="{7A2AC50E-1465-5908-D118-3F008F99595A}"/>
-          </ac:spMkLst>
-        </pc:spChg>
-      </pc:sldChg>
-      <pc:sldChg chg="modSp mod">
-        <pc:chgData name="Matthieu De Mari" userId="dfb708c9-d8dc-439f-9a3b-c772bf4a311c" providerId="ADAL" clId="{81E9B007-0C2C-493E-9B93-55A62C9C1F12}" dt="2026-01-14T08:45:47.602" v="114" actId="313"/>
-        <pc:sldMkLst>
-          <pc:docMk/>
-          <pc:sldMk cId="1643155833" sldId="469"/>
-        </pc:sldMkLst>
-        <pc:spChg chg="mod">
-          <ac:chgData name="Matthieu De Mari" userId="dfb708c9-d8dc-439f-9a3b-c772bf4a311c" providerId="ADAL" clId="{81E9B007-0C2C-493E-9B93-55A62C9C1F12}" dt="2026-01-14T08:45:47.602" v="114" actId="313"/>
-          <ac:spMkLst>
-            <pc:docMk/>
-            <pc:sldMk cId="1643155833" sldId="469"/>
-            <ac:spMk id="3" creationId="{C88E7E02-41CA-5502-EC81-CC1584EA1981}"/>
-          </ac:spMkLst>
-        </pc:spChg>
-      </pc:sldChg>
-      <pc:sldChg chg="modSp mod">
-        <pc:chgData name="Matthieu De Mari" userId="dfb708c9-d8dc-439f-9a3b-c772bf4a311c" providerId="ADAL" clId="{81E9B007-0C2C-493E-9B93-55A62C9C1F12}" dt="2026-01-14T08:45:41.017" v="111" actId="313"/>
-        <pc:sldMkLst>
-          <pc:docMk/>
-          <pc:sldMk cId="3784750566" sldId="478"/>
-        </pc:sldMkLst>
-        <pc:spChg chg="mod">
-          <ac:chgData name="Matthieu De Mari" userId="dfb708c9-d8dc-439f-9a3b-c772bf4a311c" providerId="ADAL" clId="{81E9B007-0C2C-493E-9B93-55A62C9C1F12}" dt="2026-01-14T08:45:41.017" v="111" actId="313"/>
-          <ac:spMkLst>
-            <pc:docMk/>
-            <pc:sldMk cId="3784750566" sldId="478"/>
-            <ac:spMk id="3" creationId="{C88E7E02-41CA-5502-EC81-CC1584EA1981}"/>
-          </ac:spMkLst>
-        </pc:spChg>
-      </pc:sldChg>
-      <pc:sldChg chg="modSp mod">
-        <pc:chgData name="Matthieu De Mari" userId="dfb708c9-d8dc-439f-9a3b-c772bf4a311c" providerId="ADAL" clId="{81E9B007-0C2C-493E-9B93-55A62C9C1F12}" dt="2026-01-14T08:48:42.334" v="155" actId="14100"/>
-        <pc:sldMkLst>
-          <pc:docMk/>
-          <pc:sldMk cId="3878320393" sldId="482"/>
-        </pc:sldMkLst>
-        <pc:spChg chg="mod">
-          <ac:chgData name="Matthieu De Mari" userId="dfb708c9-d8dc-439f-9a3b-c772bf4a311c" providerId="ADAL" clId="{81E9B007-0C2C-493E-9B93-55A62C9C1F12}" dt="2026-01-14T08:48:42.334" v="155" actId="14100"/>
-          <ac:spMkLst>
-            <pc:docMk/>
-            <pc:sldMk cId="3878320393" sldId="482"/>
-            <ac:spMk id="3" creationId="{220F8BCD-1F74-0CCD-9D50-EB70D633319C}"/>
-          </ac:spMkLst>
-        </pc:spChg>
-      </pc:sldChg>
-      <pc:sldChg chg="modSp mod">
-        <pc:chgData name="Matthieu De Mari" userId="dfb708c9-d8dc-439f-9a3b-c772bf4a311c" providerId="ADAL" clId="{81E9B007-0C2C-493E-9B93-55A62C9C1F12}" dt="2026-01-14T08:39:23.410" v="3" actId="115"/>
+        <pc:chgData name="Matthieu De Mari" userId="dfb708c9-d8dc-439f-9a3b-c772bf4a311c" providerId="ADAL" clId="{81E9B007-0C2C-493E-9B93-55A62C9C1F12}" dt="2026-02-24T02:55:42.301" v="159" actId="113"/>
         <pc:sldMkLst>
           <pc:docMk/>
           <pc:sldMk cId="1267674129" sldId="490"/>
         </pc:sldMkLst>
         <pc:spChg chg="mod">
-          <ac:chgData name="Matthieu De Mari" userId="dfb708c9-d8dc-439f-9a3b-c772bf4a311c" providerId="ADAL" clId="{81E9B007-0C2C-493E-9B93-55A62C9C1F12}" dt="2026-01-14T08:39:23.410" v="3" actId="115"/>
+          <ac:chgData name="Matthieu De Mari" userId="dfb708c9-d8dc-439f-9a3b-c772bf4a311c" providerId="ADAL" clId="{81E9B007-0C2C-493E-9B93-55A62C9C1F12}" dt="2026-02-24T02:55:42.301" v="159" actId="113"/>
           <ac:spMkLst>
             <pc:docMk/>
             <pc:sldMk cId="1267674129" sldId="490"/>
             <ac:spMk id="5" creationId="{B0003562-B0F9-FC63-4F67-49F09BA7CBB2}"/>
-          </ac:spMkLst>
-        </pc:spChg>
-      </pc:sldChg>
-      <pc:sldChg chg="modSp mod">
-        <pc:chgData name="Matthieu De Mari" userId="dfb708c9-d8dc-439f-9a3b-c772bf4a311c" providerId="ADAL" clId="{81E9B007-0C2C-493E-9B93-55A62C9C1F12}" dt="2026-01-14T08:40:31.644" v="7" actId="20577"/>
-        <pc:sldMkLst>
-          <pc:docMk/>
-          <pc:sldMk cId="756526478" sldId="497"/>
-        </pc:sldMkLst>
-        <pc:spChg chg="mod">
-          <ac:chgData name="Matthieu De Mari" userId="dfb708c9-d8dc-439f-9a3b-c772bf4a311c" providerId="ADAL" clId="{81E9B007-0C2C-493E-9B93-55A62C9C1F12}" dt="2026-01-14T08:40:31.644" v="7" actId="20577"/>
-          <ac:spMkLst>
-            <pc:docMk/>
-            <pc:sldMk cId="756526478" sldId="497"/>
-            <ac:spMk id="5" creationId="{E6A200B5-9C77-EEF0-29BA-30B546FFB1E9}"/>
           </ac:spMkLst>
         </pc:spChg>
       </pc:sldChg>
@@ -656,7 +520,7 @@
           <a:p>
             <a:fld id="{98CFC6A4-B085-437B-8084-693BEB2A32DE}" type="datetimeFigureOut">
               <a:rPr lang="en-SG" smtClean="0"/>
-              <a:t>14/1/2026</a:t>
+              <a:t>24/2/2026</a:t>
             </a:fld>
             <a:endParaRPr lang="en-SG"/>
           </a:p>
@@ -1481,7 +1345,7 @@
           <a:p>
             <a:fld id="{AB35F6B0-D468-4997-9CE3-CF2A1AE5E3F9}" type="datetimeFigureOut">
               <a:rPr lang="en-SG" smtClean="0"/>
-              <a:t>14/1/2026</a:t>
+              <a:t>24/2/2026</a:t>
             </a:fld>
             <a:endParaRPr lang="en-SG"/>
           </a:p>
@@ -1681,7 +1545,7 @@
           <a:p>
             <a:fld id="{AB35F6B0-D468-4997-9CE3-CF2A1AE5E3F9}" type="datetimeFigureOut">
               <a:rPr lang="en-SG" smtClean="0"/>
-              <a:t>14/1/2026</a:t>
+              <a:t>24/2/2026</a:t>
             </a:fld>
             <a:endParaRPr lang="en-SG"/>
           </a:p>
@@ -1891,7 +1755,7 @@
           <a:p>
             <a:fld id="{AB35F6B0-D468-4997-9CE3-CF2A1AE5E3F9}" type="datetimeFigureOut">
               <a:rPr lang="en-SG" smtClean="0"/>
-              <a:t>14/1/2026</a:t>
+              <a:t>24/2/2026</a:t>
             </a:fld>
             <a:endParaRPr lang="en-SG"/>
           </a:p>
@@ -2091,7 +1955,7 @@
           <a:p>
             <a:fld id="{AB35F6B0-D468-4997-9CE3-CF2A1AE5E3F9}" type="datetimeFigureOut">
               <a:rPr lang="en-SG" smtClean="0"/>
-              <a:t>14/1/2026</a:t>
+              <a:t>24/2/2026</a:t>
             </a:fld>
             <a:endParaRPr lang="en-SG"/>
           </a:p>
@@ -2367,7 +2231,7 @@
           <a:p>
             <a:fld id="{AB35F6B0-D468-4997-9CE3-CF2A1AE5E3F9}" type="datetimeFigureOut">
               <a:rPr lang="en-SG" smtClean="0"/>
-              <a:t>14/1/2026</a:t>
+              <a:t>24/2/2026</a:t>
             </a:fld>
             <a:endParaRPr lang="en-SG"/>
           </a:p>
@@ -2635,7 +2499,7 @@
           <a:p>
             <a:fld id="{AB35F6B0-D468-4997-9CE3-CF2A1AE5E3F9}" type="datetimeFigureOut">
               <a:rPr lang="en-SG" smtClean="0"/>
-              <a:t>14/1/2026</a:t>
+              <a:t>24/2/2026</a:t>
             </a:fld>
             <a:endParaRPr lang="en-SG"/>
           </a:p>
@@ -3050,7 +2914,7 @@
           <a:p>
             <a:fld id="{AB35F6B0-D468-4997-9CE3-CF2A1AE5E3F9}" type="datetimeFigureOut">
               <a:rPr lang="en-SG" smtClean="0"/>
-              <a:t>14/1/2026</a:t>
+              <a:t>24/2/2026</a:t>
             </a:fld>
             <a:endParaRPr lang="en-SG"/>
           </a:p>
@@ -3192,7 +3056,7 @@
           <a:p>
             <a:fld id="{AB35F6B0-D468-4997-9CE3-CF2A1AE5E3F9}" type="datetimeFigureOut">
               <a:rPr lang="en-SG" smtClean="0"/>
-              <a:t>14/1/2026</a:t>
+              <a:t>24/2/2026</a:t>
             </a:fld>
             <a:endParaRPr lang="en-SG"/>
           </a:p>
@@ -3305,7 +3169,7 @@
           <a:p>
             <a:fld id="{AB35F6B0-D468-4997-9CE3-CF2A1AE5E3F9}" type="datetimeFigureOut">
               <a:rPr lang="en-SG" smtClean="0"/>
-              <a:t>14/1/2026</a:t>
+              <a:t>24/2/2026</a:t>
             </a:fld>
             <a:endParaRPr lang="en-SG"/>
           </a:p>
@@ -3618,7 +3482,7 @@
           <a:p>
             <a:fld id="{AB35F6B0-D468-4997-9CE3-CF2A1AE5E3F9}" type="datetimeFigureOut">
               <a:rPr lang="en-SG" smtClean="0"/>
-              <a:t>14/1/2026</a:t>
+              <a:t>24/2/2026</a:t>
             </a:fld>
             <a:endParaRPr lang="en-SG"/>
           </a:p>
@@ -3907,7 +3771,7 @@
           <a:p>
             <a:fld id="{AB35F6B0-D468-4997-9CE3-CF2A1AE5E3F9}" type="datetimeFigureOut">
               <a:rPr lang="en-SG" smtClean="0"/>
-              <a:t>14/1/2026</a:t>
+              <a:t>24/2/2026</a:t>
             </a:fld>
             <a:endParaRPr lang="en-SG"/>
           </a:p>
@@ -4150,7 +4014,7 @@
           <a:p>
             <a:fld id="{AB35F6B0-D468-4997-9CE3-CF2A1AE5E3F9}" type="datetimeFigureOut">
               <a:rPr lang="en-SG" smtClean="0"/>
-              <a:t>14/1/2026</a:t>
+              <a:t>24/2/2026</a:t>
             </a:fld>
             <a:endParaRPr lang="en-SG"/>
           </a:p>
@@ -21400,17 +21264,8 @@
             </a:r>
             <a:r>
               <a:rPr lang="en-GB" dirty="0"/>
-              <a:t>instead</a:t>
-            </a:r>
-            <a:r>
-              <a:rPr lang="en-GB" b="1" dirty="0">
-                <a:solidFill>
-                  <a:srgbClr val="7030A0"/>
-                </a:solidFill>
-              </a:rPr>
-              <a:t>.</a:t>
-            </a:r>
-            <a:endParaRPr lang="en-GB" dirty="0"/>
+              <a:t>instead.</a:t>
+            </a:r>
           </a:p>
           <a:p>
             <a:pPr marL="0" indent="0">
@@ -24165,7 +24020,15 @@
             </a:r>
             <a:r>
               <a:rPr lang="en-GB" dirty="0"/>
-              <a:t>, consists of </a:t>
+              <a:t>, the </a:t>
+            </a:r>
+            <a:r>
+              <a:rPr lang="en-GB" dirty="0" err="1"/>
+              <a:t>RegEx</a:t>
+            </a:r>
+            <a:r>
+              <a:rPr lang="en-GB" dirty="0"/>
+              <a:t> “^a+$” consists of </a:t>
             </a:r>
             <a:r>
               <a:rPr lang="en-GB" b="1" dirty="0"/>
@@ -24292,8 +24155,8 @@
           </a:p>
         </p:txBody>
       </p:sp>
-      <mc:AlternateContent xmlns:mc="http://schemas.openxmlformats.org/markup-compatibility/2006" xmlns:a14="http://schemas.microsoft.com/office/drawing/2010/main">
-        <mc:Choice Requires="a14">
+      <mc:AlternateContent xmlns:mc="http://schemas.openxmlformats.org/markup-compatibility/2006">
+        <mc:Choice xmlns:a14="http://schemas.microsoft.com/office/drawing/2010/main" Requires="a14">
           <p:sp>
             <p:nvSpPr>
               <p:cNvPr id="5" name="Content Placeholder 4">
@@ -24450,7 +24313,15 @@
                 </a:r>
                 <a:r>
                   <a:rPr lang="en-GB" dirty="0"/>
-                  <a:t>, consists of </a:t>
+                  <a:t>, the </a:t>
+                </a:r>
+                <a:r>
+                  <a:rPr lang="en-GB" dirty="0" err="1"/>
+                  <a:t>RegEx</a:t>
+                </a:r>
+                <a:r>
+                  <a:rPr lang="en-GB" dirty="0"/>
+                  <a:t> “^a?$” consists of </a:t>
                 </a:r>
                 <a:r>
                   <a:rPr lang="en-GB" b="1" dirty="0"/>
@@ -24551,7 +24422,7 @@
             </p:txBody>
           </p:sp>
         </mc:Choice>
-        <mc:Fallback xmlns="">
+        <mc:Fallback>
           <p:sp>
             <p:nvSpPr>
               <p:cNvPr id="5" name="Content Placeholder 4">
@@ -25357,7 +25228,7 @@
             </a:pPr>
             <a:r>
               <a:rPr lang="en-GB" dirty="0"/>
-              <a:t>(</a:t>
+              <a:t>^(</a:t>
             </a:r>
             <a:r>
               <a:rPr lang="en-GB" dirty="0" err="1"/>
@@ -25365,7 +25236,7 @@
             </a:r>
             <a:r>
               <a:rPr lang="en-GB" dirty="0"/>
-              <a:t>)at</a:t>
+              <a:t>)?at$</a:t>
             </a:r>
           </a:p>
           <a:p>
@@ -25537,7 +25408,7 @@
             </a:pPr>
             <a:r>
               <a:rPr lang="en-GB" dirty="0"/>
-              <a:t>(</a:t>
+              <a:t>^(</a:t>
             </a:r>
             <a:r>
               <a:rPr lang="en-GB" dirty="0" err="1"/>
@@ -25545,7 +25416,7 @@
             </a:r>
             <a:r>
               <a:rPr lang="en-GB" dirty="0"/>
-              <a:t>)at</a:t>
+              <a:t>)?at$</a:t>
             </a:r>
           </a:p>
           <a:p>
@@ -26884,15 +26755,15 @@
               <a:buNone/>
             </a:pPr>
             <a:r>
-              <a:rPr lang="en-SG" dirty="0"/>
+              <a:rPr lang="en-SG" strike="sngStrike" dirty="0"/>
               <a:t>Q2 (cannot be solved for now, get back to it later): Could that be described using a </a:t>
             </a:r>
             <a:r>
-              <a:rPr lang="en-SG" dirty="0" err="1"/>
+              <a:rPr lang="en-SG" strike="sngStrike" dirty="0" err="1"/>
               <a:t>RegEx</a:t>
             </a:r>
             <a:r>
-              <a:rPr lang="en-SG" dirty="0"/>
+              <a:rPr lang="en-SG" strike="sngStrike" dirty="0"/>
               <a:t> of some sort?</a:t>
             </a:r>
           </a:p>

</xml_diff>